<commit_message>
feat: Add Pan-India GIS Land Governance features, Auth fixes, and SQLite User Management Studio
</commit_message>
<xml_diff>
--- a/BhoomiShield_SIH2026_TEAM_AGNI.pptx
+++ b/BhoomiShield_SIH2026_TEAM_AGNI.pptx
@@ -3110,7 +3110,7 @@
         <p:spPr>
           <a:xfrm>
             <a:off x="731520" y="320040"/>
-            <a:ext cx="9144000" cy="731520"/>
+            <a:ext cx="8686800" cy="731520"/>
           </a:xfrm>
           <a:prstGeom prst="rect">
             <a:avLst/>
@@ -3124,7 +3124,7 @@
           <a:lstStyle/>
           <a:p>
             <a:pPr>
-              <a:defRPr b="1" sz="3000">
+              <a:defRPr b="1" sz="3200">
                 <a:solidFill>
                   <a:srgbClr val="0F3D6B"/>
                 </a:solidFill>
@@ -3152,8 +3152,8 @@
         </p:blipFill>
         <p:spPr>
           <a:xfrm>
-            <a:off x="10149840" y="182880"/>
-            <a:ext cx="1645920" cy="777053"/>
+            <a:off x="10058400" y="182880"/>
+            <a:ext cx="1737360" cy="820223"/>
           </a:xfrm>
           <a:prstGeom prst="rect">
             <a:avLst/>
@@ -3197,399 +3197,189 @@
       </p:sp>
       <p:sp>
         <p:nvSpPr>
-          <p:cNvPr id="5" name="Rounded Rectangle 4"/>
-          <p:cNvSpPr/>
+          <p:cNvPr id="5" name="TextBox 4"/>
+          <p:cNvSpPr txBox="1"/>
           <p:nvPr/>
         </p:nvSpPr>
         <p:spPr>
           <a:xfrm>
-            <a:off x="731520" y="1600200"/>
-            <a:ext cx="6858000" cy="4846320"/>
+            <a:off x="731520" y="1645920"/>
+            <a:ext cx="6949440" cy="4754880"/>
           </a:xfrm>
-          <a:prstGeom prst="roundRect">
+          <a:prstGeom prst="rect">
             <a:avLst/>
           </a:prstGeom>
-          <a:solidFill>
-            <a:srgbClr val="F8FAFC"/>
-          </a:solidFill>
-          <a:ln w="19050">
-            <a:solidFill>
-              <a:srgbClr val="CBD5E1"/>
-            </a:solidFill>
-          </a:ln>
+          <a:noFill/>
         </p:spPr>
-        <p:style>
-          <a:lnRef idx="1">
-            <a:schemeClr val="accent1"/>
-          </a:lnRef>
-          <a:fillRef idx="3">
-            <a:schemeClr val="accent1"/>
-          </a:fillRef>
-          <a:effectRef idx="2">
-            <a:schemeClr val="accent1"/>
-          </a:effectRef>
-          <a:fontRef idx="minor">
-            <a:schemeClr val="lt1"/>
-          </a:fontRef>
-        </p:style>
-        <p:txBody>
-          <a:bodyPr rtlCol="0" anchor="ctr" wrap="square" lIns="274320" rIns="274320" tIns="274320"/>
-          <a:lstStyle/>
-          <a:p>
-            <a:pPr algn="ctr">
-              <a:spcAft>
-                <a:spcPts val="1000"/>
-              </a:spcAft>
-            </a:pPr>
-            <a:r>
-              <a:rPr b="1" sz="1300">
-                <a:solidFill>
-                  <a:srgbClr val="0F172A"/>
-                </a:solidFill>
-              </a:rPr>
-              <a:t>• Problem Statement ID – </a:t>
-            </a:r>
-            <a:r>
-              <a:rPr b="1" sz="1300">
-                <a:solidFill>
-                  <a:srgbClr val="D97706"/>
-                </a:solidFill>
-              </a:rPr>
-              <a:t>SIH26014</a:t>
-            </a:r>
-          </a:p>
+        <p:txBody>
+          <a:bodyPr wrap="square">
+            <a:spAutoFit/>
+          </a:bodyPr>
+          <a:lstStyle/>
           <a:p>
             <a:pPr>
               <a:spcAft>
-                <a:spcPts val="1000"/>
+                <a:spcPts val="1200"/>
               </a:spcAft>
             </a:pPr>
             <a:r>
-              <a:rPr b="1" sz="1300">
+              <a:rPr b="1" sz="1350">
                 <a:solidFill>
                   <a:srgbClr val="0F172A"/>
                 </a:solidFill>
               </a:rPr>
-              <a:t>• Problem Statement Title – </a:t>
-            </a:r>
-            <a:r>
-              <a:rPr b="1" sz="1300">
-                <a:solidFill>
-                  <a:srgbClr val="0F3D6B"/>
-                </a:solidFill>
-              </a:rPr>
-              <a:t>BhoomiShield: AI-Powered Pan-India Land Record Governance, Cadastral GIS &amp; Multi-Jurisdictional Fraud Prevention Engine</a:t>
+              <a:t>• Problem Statement ID – </a:t>
+            </a:r>
+            <a:r>
+              <a:rPr b="1" sz="1350">
+                <a:solidFill>
+                  <a:srgbClr val="D97706"/>
+                </a:solidFill>
+              </a:rPr>
+              <a:t>SIH26014</a:t>
             </a:r>
           </a:p>
           <a:p>
             <a:pPr>
               <a:spcAft>
-                <a:spcPts val="1000"/>
+                <a:spcPts val="1200"/>
               </a:spcAft>
             </a:pPr>
             <a:r>
-              <a:rPr b="1" sz="1300">
+              <a:rPr b="1" sz="1350">
                 <a:solidFill>
                   <a:srgbClr val="0F172A"/>
                 </a:solidFill>
               </a:rPr>
-              <a:t>• Theme – </a:t>
-            </a:r>
-            <a:r>
-              <a:rPr b="1" sz="1300">
-                <a:solidFill>
-                  <a:srgbClr val="0F172A"/>
-                </a:solidFill>
-              </a:rPr>
-              <a:t>Smart Governance / Digital India / Land Administration Modernization</a:t>
+              <a:t>• Problem Statement Title- </a:t>
+            </a:r>
+            <a:r>
+              <a:rPr b="1" sz="1350">
+                <a:solidFill>
+                  <a:srgbClr val="0F3D6B"/>
+                </a:solidFill>
+              </a:rPr>
+              <a:t>BhoomiShield: Pan-India AI Land Record Governance, Cadastral GIS Mapping &amp; Multi-Jurisdictional Fraud Prevention Engine</a:t>
             </a:r>
           </a:p>
           <a:p>
             <a:pPr>
               <a:spcAft>
-                <a:spcPts val="1000"/>
+                <a:spcPts val="1200"/>
               </a:spcAft>
             </a:pPr>
             <a:r>
-              <a:rPr b="1" sz="1300">
+              <a:rPr b="1" sz="1350">
                 <a:solidFill>
                   <a:srgbClr val="0F172A"/>
                 </a:solidFill>
               </a:rPr>
-              <a:t>• PS Category – </a:t>
-            </a:r>
-            <a:r>
-              <a:rPr b="1" sz="1300">
-                <a:solidFill>
-                  <a:srgbClr val="2563EB"/>
-                </a:solidFill>
-              </a:rPr>
-              <a:t>Software</a:t>
+              <a:t>• Theme- </a:t>
+            </a:r>
+            <a:r>
+              <a:rPr b="1" sz="1350">
+                <a:solidFill>
+                  <a:srgbClr val="0F172A"/>
+                </a:solidFill>
+              </a:rPr>
+              <a:t>Smart Governance / Digital India / Land Administration Modernization</a:t>
             </a:r>
           </a:p>
           <a:p>
             <a:pPr>
               <a:spcAft>
-                <a:spcPts val="1000"/>
+                <a:spcPts val="1200"/>
               </a:spcAft>
             </a:pPr>
             <a:r>
-              <a:rPr b="1" sz="1300">
+              <a:rPr b="1" sz="1350">
                 <a:solidFill>
                   <a:srgbClr val="0F172A"/>
                 </a:solidFill>
               </a:rPr>
-              <a:t>• Team ID / Leader Roll No – </a:t>
-            </a:r>
-            <a:r>
-              <a:rPr b="1" sz="1300">
-                <a:solidFill>
-                  <a:srgbClr val="0F172A"/>
-                </a:solidFill>
-              </a:rPr>
-              <a:t>2404921540161</a:t>
+              <a:t>• PS Category- Software/Hardware </a:t>
+            </a:r>
+            <a:r>
+              <a:rPr b="1" sz="1350">
+                <a:solidFill>
+                  <a:srgbClr val="2563EB"/>
+                </a:solidFill>
+              </a:rPr>
+              <a:t>Software</a:t>
             </a:r>
           </a:p>
           <a:p>
             <a:pPr>
               <a:spcAft>
-                <a:spcPts val="1000"/>
+                <a:spcPts val="1200"/>
               </a:spcAft>
             </a:pPr>
             <a:r>
-              <a:rPr b="1" sz="1300">
+              <a:rPr b="1" sz="1350">
                 <a:solidFill>
                   <a:srgbClr val="0F172A"/>
                 </a:solidFill>
               </a:rPr>
-              <a:t>• Team Name (Registered on portal) – </a:t>
-            </a:r>
-            <a:r>
-              <a:rPr b="1" sz="1300">
-                <a:solidFill>
-                  <a:srgbClr val="D97706"/>
-                </a:solidFill>
-              </a:rPr>
-              <a:t>TEAM AGNI</a:t>
+              <a:t>• Team ID- </a:t>
+            </a:r>
+            <a:r>
+              <a:rPr b="1" sz="1350">
+                <a:solidFill>
+                  <a:srgbClr val="0F172A"/>
+                </a:solidFill>
+              </a:rPr>
+              <a:t>2404921540161</a:t>
             </a:r>
           </a:p>
           <a:p>
             <a:pPr>
               <a:spcAft>
-                <a:spcPts val="1000"/>
+                <a:spcPts val="1200"/>
               </a:spcAft>
             </a:pPr>
             <a:r>
-              <a:rPr b="1" sz="1300">
+              <a:rPr b="1" sz="1350">
                 <a:solidFill>
                   <a:srgbClr val="0F172A"/>
                 </a:solidFill>
               </a:rPr>
-              <a:t>• Team Leader – </a:t>
-            </a:r>
-            <a:r>
-              <a:rPr b="1" sz="1300">
-                <a:solidFill>
-                  <a:srgbClr val="0F172A"/>
-                </a:solidFill>
-              </a:rPr>
-              <a:t>Priyanshu kumar yadav</a:t>
-            </a:r>
-          </a:p>
-        </p:txBody>
-      </p:sp>
-      <p:sp>
-        <p:nvSpPr>
-          <p:cNvPr id="6" name="Rounded Rectangle 5"/>
-          <p:cNvSpPr/>
+              <a:t>• Team Name (Registered on portal) </a:t>
+            </a:r>
+            <a:r>
+              <a:rPr b="1" sz="1350">
+                <a:solidFill>
+                  <a:srgbClr val="D97706"/>
+                </a:solidFill>
+              </a:rPr>
+              <a:t>TEAM AGNI (Leader: Priyanshu kumar yadav)</a:t>
+            </a:r>
+          </a:p>
+        </p:txBody>
+      </p:sp>
+      <p:pic>
+        <p:nvPicPr>
+          <p:cNvPr id="6" name="Picture 5" descr="brain_bulb_clean_final.png"/>
+          <p:cNvPicPr>
+            <a:picLocks noChangeAspect="1"/>
+          </p:cNvPicPr>
           <p:nvPr/>
-        </p:nvSpPr>
+        </p:nvPicPr>
+        <p:blipFill>
+          <a:blip r:embed="rId3"/>
+          <a:stretch>
+            <a:fillRect/>
+          </a:stretch>
+        </p:blipFill>
         <p:spPr>
           <a:xfrm>
-            <a:off x="7772400" y="1600200"/>
-            <a:ext cx="3657600" cy="4846320"/>
+            <a:off x="8046720" y="1554480"/>
+            <a:ext cx="3291840" cy="4983165"/>
           </a:xfrm>
-          <a:prstGeom prst="roundRect">
+          <a:prstGeom prst="rect">
             <a:avLst/>
           </a:prstGeom>
-          <a:solidFill>
-            <a:srgbClr val="EEF6FF"/>
-          </a:solidFill>
-          <a:ln w="19050">
-            <a:solidFill>
-              <a:srgbClr val="2563EB"/>
-            </a:solidFill>
-          </a:ln>
         </p:spPr>
-        <p:style>
-          <a:lnRef idx="1">
-            <a:schemeClr val="accent1"/>
-          </a:lnRef>
-          <a:fillRef idx="3">
-            <a:schemeClr val="accent1"/>
-          </a:fillRef>
-          <a:effectRef idx="2">
-            <a:schemeClr val="accent1"/>
-          </a:effectRef>
-          <a:fontRef idx="minor">
-            <a:schemeClr val="lt1"/>
-          </a:fontRef>
-        </p:style>
-        <p:txBody>
-          <a:bodyPr rtlCol="0" anchor="ctr" wrap="square" lIns="228600" rIns="228600" tIns="228600"/>
-          <a:lstStyle/>
-          <a:p>
-            <a:pPr algn="ctr">
-              <a:spcAft>
-                <a:spcPts val="800"/>
-              </a:spcAft>
-              <a:defRPr b="1" sz="1350">
-                <a:solidFill>
-                  <a:srgbClr val="0F3D6B"/>
-                </a:solidFill>
-              </a:defRPr>
-            </a:pPr>
-            <a:r>
-              <a:t>PROPOSED INNOVATION</a:t>
-            </a:r>
-          </a:p>
-          <a:p>
-            <a:pPr>
-              <a:defRPr b="1" sz="1050">
-                <a:solidFill>
-                  <a:srgbClr val="2563EB"/>
-                </a:solidFill>
-              </a:defRPr>
-            </a:pPr>
-            <a:r>
-              <a:t>🌐 Pan-India Live Ingestion</a:t>
-            </a:r>
-          </a:p>
-          <a:p>
-            <a:pPr>
-              <a:spcAft>
-                <a:spcPts val="600"/>
-              </a:spcAft>
-              <a:defRPr sz="950">
-                <a:solidFill>
-                  <a:srgbClr val="0F172A"/>
-                </a:solidFill>
-              </a:defRPr>
-            </a:pPr>
-            <a:r>
-              <a:t>28 States &amp; 8 UTs land registry integration (Khatiyan, RoR, 7/12, Patta).</a:t>
-            </a:r>
-          </a:p>
-          <a:p>
-            <a:pPr>
-              <a:defRPr b="1" sz="1050">
-                <a:solidFill>
-                  <a:srgbClr val="2563EB"/>
-                </a:solidFill>
-              </a:defRPr>
-            </a:pPr>
-            <a:r>
-              <a:t>🗺️ Cadastral GIS &amp; GPS Search</a:t>
-            </a:r>
-          </a:p>
-          <a:p>
-            <a:pPr>
-              <a:spcAft>
-                <a:spcPts val="600"/>
-              </a:spcAft>
-              <a:defRPr sz="950">
-                <a:solidFill>
-                  <a:srgbClr val="0F172A"/>
-                </a:solidFill>
-              </a:defRPr>
-            </a:pPr>
-            <a:r>
-              <a:t>Satellite parcel mapping, Ray-Casting Point-in-Polygon boundary detection.</a:t>
-            </a:r>
-          </a:p>
-          <a:p>
-            <a:pPr>
-              <a:defRPr b="1" sz="1050">
-                <a:solidFill>
-                  <a:srgbClr val="2563EB"/>
-                </a:solidFill>
-              </a:defRPr>
-            </a:pPr>
-            <a:r>
-              <a:t>🛡️ 7-Rule AI Risk Engine</a:t>
-            </a:r>
-          </a:p>
-          <a:p>
-            <a:pPr>
-              <a:spcAft>
-                <a:spcPts val="600"/>
-              </a:spcAft>
-              <a:defRPr sz="950">
-                <a:solidFill>
-                  <a:srgbClr val="0F172A"/>
-                </a:solidFill>
-              </a:defRPr>
-            </a:pPr>
-            <a:r>
-              <a:t>Deterministic 0-100 scoring for owner mismatch, area variance &amp; court stays.</a:t>
-            </a:r>
-          </a:p>
-          <a:p>
-            <a:pPr>
-              <a:defRPr b="1" sz="1050">
-                <a:solidFill>
-                  <a:srgbClr val="2563EB"/>
-                </a:solidFill>
-              </a:defRPr>
-            </a:pPr>
-            <a:r>
-              <a:t>🔐 Citizen Bhoomi Vault</a:t>
-            </a:r>
-          </a:p>
-          <a:p>
-            <a:pPr>
-              <a:spcAft>
-                <a:spcPts val="600"/>
-              </a:spcAft>
-              <a:defRPr sz="950">
-                <a:solidFill>
-                  <a:srgbClr val="0F172A"/>
-                </a:solidFill>
-              </a:defRPr>
-            </a:pPr>
-            <a:r>
-              <a:t>SHA-256 cryptographic document store &amp; tamper-proof QR audit reports.</a:t>
-            </a:r>
-          </a:p>
-          <a:p>
-            <a:pPr>
-              <a:defRPr b="1" sz="1050">
-                <a:solidFill>
-                  <a:srgbClr val="2563EB"/>
-                </a:solidFill>
-              </a:defRPr>
-            </a:pPr>
-            <a:r>
-              <a:t>🗣️ 11-Language Multimodal AI</a:t>
-            </a:r>
-          </a:p>
-          <a:p>
-            <a:pPr>
-              <a:spcAft>
-                <a:spcPts val="600"/>
-              </a:spcAft>
-              <a:defRPr sz="950">
-                <a:solidFill>
-                  <a:srgbClr val="0F172A"/>
-                </a:solidFill>
-              </a:defRPr>
-            </a:pPr>
-            <a:r>
-              <a:t>Voice/Text legal guidance in Hindi, Bengali, Tamil, Telugu, Marathi, etc.</a:t>
-            </a:r>
-          </a:p>
-        </p:txBody>
-      </p:sp>
+      </p:pic>
     </p:spTree>
   </p:cSld>
   <p:clrMapOvr>
@@ -3690,8 +3480,8 @@
         </p:nvSpPr>
         <p:spPr>
           <a:xfrm>
-            <a:off x="2103120" y="274320"/>
-            <a:ext cx="8046720" cy="822960"/>
+            <a:off x="2103120" y="228600"/>
+            <a:ext cx="7955279" cy="868680"/>
           </a:xfrm>
           <a:prstGeom prst="rect">
             <a:avLst/>
@@ -3734,7 +3524,7 @@
         <p:spPr>
           <a:xfrm>
             <a:off x="10241280" y="182880"/>
-            <a:ext cx="1554480" cy="733884"/>
+            <a:ext cx="1600200" cy="755469"/>
           </a:xfrm>
           <a:prstGeom prst="rect">
             <a:avLst/>
@@ -3880,7 +3670,7 @@
               </a:defRPr>
             </a:pPr>
             <a:r>
-              <a:t>• Detailed Explanation of the Proposed Solution</a:t>
+              <a:t>• Detailed Explanation of Proposed Solution</a:t>
             </a:r>
           </a:p>
           <a:p>
@@ -4132,7 +3922,7 @@
               </a:defRPr>
             </a:pPr>
             <a:r>
-              <a:t>• Innovation and Uniqueness of the Solution</a:t>
+              <a:t>• Innovation and Uniqueness of Solution</a:t>
             </a:r>
           </a:p>
           <a:p>
@@ -4306,8 +4096,8 @@
         </p:nvSpPr>
         <p:spPr>
           <a:xfrm>
-            <a:off x="2103120" y="274320"/>
-            <a:ext cx="8046720" cy="822960"/>
+            <a:off x="2103120" y="228600"/>
+            <a:ext cx="7955279" cy="868680"/>
           </a:xfrm>
           <a:prstGeom prst="rect">
             <a:avLst/>
@@ -4350,7 +4140,7 @@
         <p:spPr>
           <a:xfrm>
             <a:off x="10241280" y="182880"/>
-            <a:ext cx="1554480" cy="733884"/>
+            <a:ext cx="1600200" cy="755469"/>
           </a:xfrm>
           <a:prstGeom prst="rect">
             <a:avLst/>
@@ -4454,14 +4244,14 @@
               <a:spcAft>
                 <a:spcPts val="600"/>
               </a:spcAft>
-              <a:defRPr b="1" sz="1300">
+              <a:defRPr b="1" sz="1200">
                 <a:solidFill>
                   <a:srgbClr val="0F3D6B"/>
                 </a:solidFill>
               </a:defRPr>
             </a:pPr>
             <a:r>
-              <a:t>• Technologies to be used</a:t>
+              <a:t>• Technologies to be used (e.g. languages, frameworks, hardware)</a:t>
             </a:r>
           </a:p>
           <a:p>
@@ -4649,14 +4439,14 @@
               <a:spcAft>
                 <a:spcPts val="600"/>
               </a:spcAft>
-              <a:defRPr b="1" sz="1300">
+              <a:defRPr b="1" sz="1200">
                 <a:solidFill>
                   <a:srgbClr val="D97706"/>
                 </a:solidFill>
               </a:defRPr>
             </a:pPr>
             <a:r>
-              <a:t>• Methodology &amp; Process for Implementation</a:t>
+              <a:t>• Methodology &amp; Process for Implementation (Working Prototype)</a:t>
             </a:r>
           </a:p>
           <a:p>
@@ -4857,8 +4647,8 @@
         </p:nvSpPr>
         <p:spPr>
           <a:xfrm>
-            <a:off x="2103120" y="274320"/>
-            <a:ext cx="8046720" cy="822960"/>
+            <a:off x="2103120" y="228600"/>
+            <a:ext cx="7955279" cy="868680"/>
           </a:xfrm>
           <a:prstGeom prst="rect">
             <a:avLst/>
@@ -4901,7 +4691,7 @@
         <p:spPr>
           <a:xfrm>
             <a:off x="10241280" y="182880"/>
-            <a:ext cx="1554480" cy="733884"/>
+            <a:ext cx="1600200" cy="755469"/>
           </a:xfrm>
           <a:prstGeom prst="rect">
             <a:avLst/>
@@ -5012,7 +4802,7 @@
               </a:defRPr>
             </a:pPr>
             <a:r>
-              <a:t>• Analysis of Feasibility</a:t>
+              <a:t>• Analysis of the Feasibility of the Idea</a:t>
             </a:r>
           </a:p>
           <a:p>
@@ -5027,7 +4817,7 @@
                   <a:srgbClr val="0F172A"/>
                 </a:solidFill>
               </a:rPr>
-              <a:t>✔ Technical Feasibility:</a:t>
+              <a:t>✔ Deterministic 0–100 AI Risk Engine:</a:t>
             </a:r>
             <a:r>
               <a:rPr sz="950">
@@ -5035,7 +4825,7 @@
                   <a:srgbClr val="475569"/>
                 </a:solidFill>
               </a:rPr>
-              <a:t> Fully functional working prototype deployed with 10,000+ parcels across Jharkhand, UP, Maharashtra, and pan-India states with sub-150ms query latency.</a:t>
+              <a:t> Heuristic rule-based scoring (R001–R007) ensuring transparent, fully explainable risk factors with zero hallucination.</a:t>
             </a:r>
           </a:p>
           <a:p>
@@ -5050,7 +4840,7 @@
                   <a:srgbClr val="0F172A"/>
                 </a:solidFill>
               </a:rPr>
-              <a:t>✔ Operational Feasibility:</a:t>
+              <a:t>✔ Multilingual Voice Legal Assistant:</a:t>
             </a:r>
             <a:r>
               <a:rPr sz="950">
@@ -5058,7 +4848,7 @@
                   <a:srgbClr val="475569"/>
                 </a:solidFill>
               </a:rPr>
-              <a:t> Non-invasive architecture that operates as an analytical intelligence layer over existing state databases without requiring costly database re-engineering.</a:t>
+              <a:t> Conversational legal aid and dispute drafting in 11 Indian regional languages for high rural accessibility.</a:t>
             </a:r>
           </a:p>
           <a:p>
@@ -5073,7 +4863,7 @@
                   <a:srgbClr val="0F172A"/>
                 </a:solidFill>
               </a:rPr>
-              <a:t>✔ Financial Viability:</a:t>
+              <a:t>✔ Cryptographic SHA-256 Audit Trail:</a:t>
             </a:r>
             <a:r>
               <a:rPr sz="950">
@@ -5081,7 +4871,7 @@
                   <a:srgbClr val="475569"/>
                 </a:solidFill>
               </a:rPr>
-              <a:t> Built on high-performance open-source stack (FastAPI, React, SQLite/PostgreSQL, Leaflet) minimizing infrastructure and licensing overhead.</a:t>
+              <a:t> Generates QR-coded official Land Health Certificates verifying textual &amp; spatial consistency across state archives.</a:t>
             </a:r>
           </a:p>
         </p:txBody>
@@ -5153,7 +4943,7 @@
                   <a:srgbClr val="0F172A"/>
                 </a:solidFill>
               </a:rPr>
-              <a:t>✔ Heterogeneous Terminology:</a:t>
+              <a:t>✔ Deterministic 0–100 AI Risk Engine:</a:t>
             </a:r>
             <a:r>
               <a:rPr sz="950">
@@ -5161,7 +4951,7 @@
                   <a:srgbClr val="475569"/>
                 </a:solidFill>
               </a:rPr>
-              <a:t> Varied state revenue terminologies (Khatian, RoR, 7/12, Jamabandi, Patta, Chitta, Dag) across different state jurisdictions.</a:t>
+              <a:t> Heuristic rule-based scoring (R001–R007) ensuring transparent, fully explainable risk factors with zero hallucination.</a:t>
             </a:r>
           </a:p>
           <a:p>
@@ -5176,7 +4966,7 @@
                   <a:srgbClr val="0F172A"/>
                 </a:solidFill>
               </a:rPr>
-              <a:t>✔ State Portal Downtime &amp; Anti-Scraping:</a:t>
+              <a:t>✔ Multilingual Voice Legal Assistant:</a:t>
             </a:r>
             <a:r>
               <a:rPr sz="950">
@@ -5184,7 +4974,7 @@
                   <a:srgbClr val="475569"/>
                 </a:solidFill>
               </a:rPr>
-              <a:t> Legacy government servers experience intermittent downtime and strict IP rate-limiting during peak daytime traffic.</a:t>
+              <a:t> Conversational legal aid and dispute drafting in 11 Indian regional languages for high rural accessibility.</a:t>
             </a:r>
           </a:p>
           <a:p>
@@ -5199,7 +4989,7 @@
                   <a:srgbClr val="0F172A"/>
                 </a:solidFill>
               </a:rPr>
-              <a:t>✔ Digital Literacy in Rural India:</a:t>
+              <a:t>✔ Cryptographic SHA-256 Audit Trail:</a:t>
             </a:r>
             <a:r>
               <a:rPr sz="950">
@@ -5207,7 +4997,7 @@
                   <a:srgbClr val="475569"/>
                 </a:solidFill>
               </a:rPr>
-              <a:t> Complex land laws and technical legal terminology pose adoption hurdles for rural farmers and non-English speakers.</a:t>
+              <a:t> Generates QR-coded official Land Health Certificates verifying textual &amp; spatial consistency across state archives.</a:t>
             </a:r>
           </a:p>
         </p:txBody>
@@ -5279,7 +5069,7 @@
                   <a:srgbClr val="0F172A"/>
                 </a:solidFill>
               </a:rPr>
-              <a:t>✔ Universal Canonical Data Adapter:</a:t>
+              <a:t>✔ Deterministic 0–100 AI Risk Engine:</a:t>
             </a:r>
             <a:r>
               <a:rPr sz="950">
@@ -5287,7 +5077,7 @@
                   <a:srgbClr val="475569"/>
                 </a:solidFill>
               </a:rPr>
-              <a:t> Standardizes diverse state terminologies into a unified Bhu-Aadhaar / ULPIN compliant schema automatically.</a:t>
+              <a:t> Heuristic rule-based scoring (R001–R007) ensuring transparent, fully explainable risk factors with zero hallucination.</a:t>
             </a:r>
           </a:p>
           <a:p>
@@ -5302,7 +5092,7 @@
                   <a:srgbClr val="0F172A"/>
                 </a:solidFill>
               </a:rPr>
-              <a:t>✔ Asynchronous Caching &amp; Resilient Adapters:</a:t>
+              <a:t>✔ Multilingual Voice Legal Assistant:</a:t>
             </a:r>
             <a:r>
               <a:rPr sz="950">
@@ -5310,7 +5100,7 @@
                   <a:srgbClr val="475569"/>
                 </a:solidFill>
               </a:rPr>
-              <a:t> Multi-tiered local SQLite/Redis caching layer with graceful fallback simulation to guarantee 99.9% uptime.</a:t>
+              <a:t> Conversational legal aid and dispute drafting in 11 Indian regional languages for high rural accessibility.</a:t>
             </a:r>
           </a:p>
           <a:p>
@@ -5325,7 +5115,7 @@
                   <a:srgbClr val="0F172A"/>
                 </a:solidFill>
               </a:rPr>
-              <a:t>✔ Multilingual Voice AI &amp; Color Indicators:</a:t>
+              <a:t>✔ Cryptographic SHA-256 Audit Trail:</a:t>
             </a:r>
             <a:r>
               <a:rPr sz="950">
@@ -5333,7 +5123,7 @@
                   <a:srgbClr val="475569"/>
                 </a:solidFill>
               </a:rPr>
-              <a:t> Interactive voice assistance in 11 vernacular Indian languages and intuitive Green/Yellow/Red risk badges for instant clarity.</a:t>
+              <a:t> Generates QR-coded official Land Health Certificates verifying textual &amp; spatial consistency across state archives.</a:t>
             </a:r>
           </a:p>
         </p:txBody>
@@ -5438,8 +5228,8 @@
         </p:nvSpPr>
         <p:spPr>
           <a:xfrm>
-            <a:off x="2103120" y="274320"/>
-            <a:ext cx="8046720" cy="822960"/>
+            <a:off x="2103120" y="228600"/>
+            <a:ext cx="7955279" cy="868680"/>
           </a:xfrm>
           <a:prstGeom prst="rect">
             <a:avLst/>
@@ -5482,7 +5272,7 @@
         <p:spPr>
           <a:xfrm>
             <a:off x="10241280" y="182880"/>
-            <a:ext cx="1554480" cy="733884"/>
+            <a:ext cx="1600200" cy="755469"/>
           </a:xfrm>
           <a:prstGeom prst="rect">
             <a:avLst/>
@@ -5943,8 +5733,8 @@
         </p:nvSpPr>
         <p:spPr>
           <a:xfrm>
-            <a:off x="2103120" y="274320"/>
-            <a:ext cx="8046720" cy="822960"/>
+            <a:off x="2103120" y="228600"/>
+            <a:ext cx="7955279" cy="868680"/>
           </a:xfrm>
           <a:prstGeom prst="rect">
             <a:avLst/>
@@ -5987,7 +5777,7 @@
         <p:spPr>
           <a:xfrm>
             <a:off x="10241280" y="182880"/>
-            <a:ext cx="1554480" cy="733884"/>
+            <a:ext cx="1600200" cy="755469"/>
           </a:xfrm>
           <a:prstGeom prst="rect">
             <a:avLst/>

</xml_diff>